<commit_message>
Reframe from the hackathon to the Design of Smart Cities project
The work was built for SIH PS90 and is now being submitted as coursework, so
the problem-statement framing was wrong everywhere it appeared: both decks, the
site header and footers, the README and the docs.

Renamed docs/SIH_DEMO.md to docs/DEMO_FLOW.md and the long deck to
SmartTraffic-full.pptx, since neither name meant anything outside the
competition. The content is unchanged -- what the project found does not depend
on who it was built for.
</commit_message>
<xml_diff>
--- a/docs/deck/SmartTraffic-5min.pptx
+++ b/docs/deck/SmartTraffic-5min.pptx
@@ -113,7 +113,7 @@
   <p:extLst>
     <p:ext uri="{521415D9-36F7-43E2-AB2F-B90AF26B5E84}">
       <p14:sectionLst xmlns:p14="http://schemas.microsoft.com/office/powerpoint/2010/main">
-        <p14:section name="Deck" id="{e7e61d42-661a-015c-3db8-3822732747e1}">
+        <p14:section name="Deck" id="{b09bff88-0893-e6d2-1f78-94a9157ea9a3}">
           <p14:sldIdLst>
             <p14:sldId id="256"/>
             <p14:sldId id="257"/>
@@ -2326,7 +2326,7 @@
                   <a:srgbClr val="94A7B8"/>
                 </a:solidFill>
               </a:rPr>
-              <a:t>SmartTraffic · SIH PS90</a:t>
+              <a:t>SmartTraffic · Design of Smart Cities</a:t>
             </a:r>
             <a:endParaRPr lang="en-US" sz="1000" dirty="0"/>
           </a:p>
@@ -2478,7 +2478,7 @@
                   <a:srgbClr val="94A7B8"/>
                 </a:solidFill>
               </a:rPr>
-              <a:t>SmartTraffic · SIH PS90</a:t>
+              <a:t>SmartTraffic · Design of Smart Cities</a:t>
             </a:r>
             <a:endParaRPr lang="en-US" sz="1000" dirty="0"/>
           </a:p>
@@ -2949,7 +2949,7 @@
                   <a:srgbClr val="94A7B8"/>
                 </a:solidFill>
               </a:rPr>
-              <a:t>Adaptive signal control built for lane-less Indian traffic   ·   SIH PS90</a:t>
+              <a:t>Adaptive signal control built for lane-less Indian traffic   ·   Design of Smart Cities</a:t>
             </a:r>
             <a:endParaRPr lang="en-US" sz="1800" dirty="0"/>
           </a:p>

</xml_diff>

<commit_message>
Restyle the decks to match: graphite and signal amber, no navy and cyan
The slides carried the same template signature the site did -- a navy ground, a
cyan accent and softly rounded panels. Both decks now use the palette the
subject belongs to: asphalt graphite, warm paper rather than pure white, signal
amber as the single accent, and signal green and red muted to the colours an
actual signal head uses rather than neon. Cyan is gone. Panels are square, the
way a printed report is, and figures are set in a monospace.

Caught a Cyrillic A that had slipped into one of the hex colours while editing,
which would have thrown when the theme was written. Both decks now validate,
pass geometry checks and export cleanly.
</commit_message>
<xml_diff>
--- a/docs/deck/SmartTraffic-5min.pptx
+++ b/docs/deck/SmartTraffic-5min.pptx
@@ -113,7 +113,7 @@
   <p:extLst>
     <p:ext uri="{521415D9-36F7-43E2-AB2F-B90AF26B5E84}">
       <p14:sectionLst xmlns:p14="http://schemas.microsoft.com/office/powerpoint/2010/main">
-        <p14:section name="Deck" id="{97958c77-10bd-d94f-fccd-4c024ef6b907}">
+        <p14:section name="Deck" id="{790e9daf-7150-ad02-ac18-6fd701d0d273}">
           <p14:sldIdLst>
             <p14:sldId id="256"/>
             <p14:sldId id="257"/>
@@ -147,7 +147,7 @@
             <a:pPr>
               <a:defRPr sz="1300" b="0" i="0" u="none" strike="noStrike">
                 <a:solidFill>
-                  <a:srgbClr val="44525F"/>
+                  <a:srgbClr val="57534B"/>
                 </a:solidFill>
                 <a:latin typeface="+mn-lt"/>
               </a:defRPr>
@@ -155,7 +155,7 @@
             <a:r>
               <a:rPr sz="1300" b="0" i="0" u="none" strike="noStrike">
                 <a:solidFill>
-                  <a:srgbClr val="44525F"/>
+                  <a:srgbClr val="57534B"/>
                 </a:solidFill>
                 <a:latin typeface="+mn-lt"/>
               </a:rPr>
@@ -190,7 +190,7 @@
           </c:tx>
           <c:spPr>
             <a:solidFill>
-              <a:srgbClr val="94A7B8"/>
+              <a:srgbClr val="8C887F"/>
             </a:solidFill>
             <a:effectLst/>
           </c:spPr>
@@ -204,7 +204,7 @@
                 <a:pPr>
                   <a:defRPr b="0" i="0" strike="noStrike" sz="1100" u="none">
                     <a:solidFill>
-                      <a:srgbClr val="44525F"/>
+                      <a:srgbClr val="57534B"/>
                     </a:solidFill>
                     <a:latin typeface="+mn-lt"/>
                   </a:defRPr>
@@ -279,7 +279,7 @@
           </c:tx>
           <c:spPr>
             <a:solidFill>
-              <a:srgbClr val="FFB347"/>
+              <a:srgbClr val="E8A33D"/>
             </a:solidFill>
             <a:effectLst/>
           </c:spPr>
@@ -293,7 +293,7 @@
                 <a:pPr>
                   <a:defRPr b="0" i="0" strike="noStrike" sz="1100" u="none">
                     <a:solidFill>
-                      <a:srgbClr val="44525F"/>
+                      <a:srgbClr val="57534B"/>
                     </a:solidFill>
                     <a:latin typeface="+mn-lt"/>
                   </a:defRPr>
@@ -361,7 +361,7 @@
               <a:pPr>
                 <a:defRPr b="0" i="0" strike="noStrike" sz="1100" u="none">
                   <a:solidFill>
-                    <a:srgbClr val="44525F"/>
+                    <a:srgbClr val="57534B"/>
                   </a:solidFill>
                   <a:latin typeface="+mn-lt"/>
                 </a:defRPr>
@@ -409,7 +409,7 @@
             <a:pPr>
               <a:defRPr sz="1100" b="0" i="0" u="none" strike="noStrike">
                 <a:solidFill>
-                  <a:srgbClr val="94A7B8"/>
+                  <a:srgbClr val="8C887F"/>
                 </a:solidFill>
                 <a:latin typeface="+mn-lt"/>
               </a:defRPr>
@@ -436,7 +436,7 @@
           <c:spPr>
             <a:ln w="12700" cap="flat">
               <a:solidFill>
-                <a:srgbClr val="DCE4EB"/>
+                <a:srgbClr val="D6D1C7"/>
               </a:solidFill>
               <a:prstDash val="solid"/>
               <a:round/>
@@ -463,7 +463,7 @@
             <a:pPr>
               <a:defRPr sz="1100" b="0" i="0" u="none" strike="noStrike">
                 <a:solidFill>
-                  <a:srgbClr val="94A7B8"/>
+                  <a:srgbClr val="8C887F"/>
                 </a:solidFill>
                 <a:latin typeface="+mn-lt"/>
               </a:defRPr>
@@ -493,7 +493,7 @@
           <a:pPr>
             <a:defRPr sz="1100">
               <a:solidFill>
-                <a:srgbClr val="44525F"/>
+                <a:srgbClr val="57534B"/>
               </a:solidFill>
               <a:latin typeface="+mn-lt"/>
               <a:cs typeface="+mn-lt"/>
@@ -533,7 +533,7 @@
             <a:pPr>
               <a:defRPr sz="1300" b="0" i="0" u="none" strike="noStrike">
                 <a:solidFill>
-                  <a:srgbClr val="44525F"/>
+                  <a:srgbClr val="57534B"/>
                 </a:solidFill>
                 <a:latin typeface="+mn-lt"/>
               </a:defRPr>
@@ -541,7 +541,7 @@
             <a:r>
               <a:rPr sz="1300" b="0" i="0" u="none" strike="noStrike">
                 <a:solidFill>
-                  <a:srgbClr val="44525F"/>
+                  <a:srgbClr val="57534B"/>
                 </a:solidFill>
                 <a:latin typeface="+mn-lt"/>
               </a:rPr>
@@ -576,7 +576,7 @@
           </c:tx>
           <c:spPr>
             <a:solidFill>
-              <a:srgbClr val="94A7B8"/>
+              <a:srgbClr val="8C887F"/>
             </a:solidFill>
             <a:effectLst/>
           </c:spPr>
@@ -590,7 +590,7 @@
                 <a:pPr>
                   <a:defRPr b="0" i="0" strike="noStrike" sz="1100" u="none">
                     <a:solidFill>
-                      <a:srgbClr val="44525F"/>
+                      <a:srgbClr val="57534B"/>
                     </a:solidFill>
                     <a:latin typeface="+mn-lt"/>
                   </a:defRPr>
@@ -611,7 +611,7 @@
             <c:bubble3D val="0"/>
             <c:spPr>
               <a:solidFill>
-                <a:srgbClr val="94A7B8"/>
+                <a:srgbClr val="8C887F"/>
               </a:solidFill>
               <a:effectLst/>
             </c:spPr>
@@ -622,7 +622,7 @@
             <c:bubble3D val="0"/>
             <c:spPr>
               <a:solidFill>
-                <a:srgbClr val="FF5A5A"/>
+                <a:srgbClr val="C8503F"/>
               </a:solidFill>
               <a:effectLst/>
             </c:spPr>
@@ -633,7 +633,7 @@
             <c:bubble3D val="0"/>
             <c:spPr>
               <a:solidFill>
-                <a:srgbClr val="3CE87C"/>
+                <a:srgbClr val="6AA84F"/>
               </a:solidFill>
               <a:effectLst/>
             </c:spPr>
@@ -687,7 +687,7 @@
               <a:pPr>
                 <a:defRPr b="0" i="0" strike="noStrike" sz="1100" u="none">
                   <a:solidFill>
-                    <a:srgbClr val="44525F"/>
+                    <a:srgbClr val="57534B"/>
                   </a:solidFill>
                   <a:latin typeface="+mn-lt"/>
                 </a:defRPr>
@@ -735,7 +735,7 @@
             <a:pPr>
               <a:defRPr sz="1100" b="0" i="0" u="none" strike="noStrike">
                 <a:solidFill>
-                  <a:srgbClr val="94A7B8"/>
+                  <a:srgbClr val="8C887F"/>
                 </a:solidFill>
                 <a:latin typeface="+mn-lt"/>
               </a:defRPr>
@@ -762,7 +762,7 @@
           <c:spPr>
             <a:ln w="12700" cap="flat">
               <a:solidFill>
-                <a:srgbClr val="DCE4EB"/>
+                <a:srgbClr val="D6D1C7"/>
               </a:solidFill>
               <a:prstDash val="solid"/>
               <a:round/>
@@ -789,7 +789,7 @@
             <a:pPr>
               <a:defRPr sz="1100" b="0" i="0" u="none" strike="noStrike">
                 <a:solidFill>
-                  <a:srgbClr val="94A7B8"/>
+                  <a:srgbClr val="8C887F"/>
                 </a:solidFill>
                 <a:latin typeface="+mn-lt"/>
               </a:defRPr>
@@ -839,7 +839,7 @@
             <a:pPr>
               <a:defRPr sz="1300" b="0" i="0" u="none" strike="noStrike">
                 <a:solidFill>
-                  <a:srgbClr val="44525F"/>
+                  <a:srgbClr val="57534B"/>
                 </a:solidFill>
                 <a:latin typeface="+mn-lt"/>
               </a:defRPr>
@@ -847,7 +847,7 @@
             <a:r>
               <a:rPr sz="1300" b="0" i="0" u="none" strike="noStrike">
                 <a:solidFill>
-                  <a:srgbClr val="44525F"/>
+                  <a:srgbClr val="57534B"/>
                 </a:solidFill>
                 <a:latin typeface="+mn-lt"/>
               </a:rPr>
@@ -882,7 +882,7 @@
           </c:tx>
           <c:spPr>
             <a:solidFill>
-              <a:srgbClr val="94A7B8"/>
+              <a:srgbClr val="8C887F"/>
             </a:solidFill>
             <a:effectLst/>
           </c:spPr>
@@ -896,7 +896,7 @@
                 <a:pPr>
                   <a:defRPr b="0" i="0" strike="noStrike" sz="1100" u="none">
                     <a:solidFill>
-                      <a:srgbClr val="44525F"/>
+                      <a:srgbClr val="57534B"/>
                     </a:solidFill>
                     <a:latin typeface="+mn-lt"/>
                   </a:defRPr>
@@ -917,7 +917,7 @@
             <c:bubble3D val="0"/>
             <c:spPr>
               <a:solidFill>
-                <a:srgbClr val="94A7B8"/>
+                <a:srgbClr val="8C887F"/>
               </a:solidFill>
               <a:effectLst/>
             </c:spPr>
@@ -928,7 +928,7 @@
             <c:bubble3D val="0"/>
             <c:spPr>
               <a:solidFill>
-                <a:srgbClr val="FF5A5A"/>
+                <a:srgbClr val="C8503F"/>
               </a:solidFill>
               <a:effectLst/>
             </c:spPr>
@@ -939,7 +939,7 @@
             <c:bubble3D val="0"/>
             <c:spPr>
               <a:solidFill>
-                <a:srgbClr val="3CE87C"/>
+                <a:srgbClr val="6AA84F"/>
               </a:solidFill>
               <a:effectLst/>
             </c:spPr>
@@ -993,7 +993,7 @@
               <a:pPr>
                 <a:defRPr b="0" i="0" strike="noStrike" sz="1100" u="none">
                   <a:solidFill>
-                    <a:srgbClr val="44525F"/>
+                    <a:srgbClr val="57534B"/>
                   </a:solidFill>
                   <a:latin typeface="+mn-lt"/>
                 </a:defRPr>
@@ -1041,7 +1041,7 @@
             <a:pPr>
               <a:defRPr sz="1100" b="0" i="0" u="none" strike="noStrike">
                 <a:solidFill>
-                  <a:srgbClr val="94A7B8"/>
+                  <a:srgbClr val="8C887F"/>
                 </a:solidFill>
                 <a:latin typeface="+mn-lt"/>
               </a:defRPr>
@@ -1068,7 +1068,7 @@
           <c:spPr>
             <a:ln w="12700" cap="flat">
               <a:solidFill>
-                <a:srgbClr val="DCE4EB"/>
+                <a:srgbClr val="D6D1C7"/>
               </a:solidFill>
               <a:prstDash val="solid"/>
               <a:round/>
@@ -1095,7 +1095,7 @@
             <a:pPr>
               <a:defRPr sz="1100" b="0" i="0" u="none" strike="noStrike">
                 <a:solidFill>
-                  <a:srgbClr val="94A7B8"/>
+                  <a:srgbClr val="8C887F"/>
                 </a:solidFill>
                 <a:latin typeface="+mn-lt"/>
               </a:defRPr>
@@ -2132,7 +2132,7 @@
     <p:bg>
       <p:bgPr>
         <a:solidFill>
-          <a:srgbClr val="0E1620"/>
+          <a:srgbClr val="16161A"/>
         </a:solidFill>
       </p:bgPr>
     </p:bg>
@@ -2215,7 +2215,7 @@
               <a:buNone/>
               <a:defRPr lang="en-US" sz="1800" dirty="0">
                 <a:solidFill>
-                  <a:srgbClr val="94A7B8"/>
+                  <a:srgbClr val="8C887F"/>
                 </a:solidFill>
               </a:defRPr>
             </a:lvl1pPr>
@@ -2326,7 +2326,7 @@
             <a:r>
               <a:rPr lang="en-US" sz="1000" dirty="0">
                 <a:solidFill>
-                  <a:srgbClr val="94A7B8"/>
+                  <a:srgbClr val="8C887F"/>
                 </a:solidFill>
               </a:rPr>
               <a:t>SmartTraffic · Design of Smart Cities</a:t>
@@ -2365,7 +2365,7 @@
             <a:lvl1pPr>
               <a:defRPr sz="1000">
                 <a:solidFill>
-                  <a:srgbClr val="94A7B8"/>
+                  <a:srgbClr val="8C887F"/>
                 </a:solidFill>
               </a:defRPr>
             </a:lvl1pPr>
@@ -2394,7 +2394,7 @@
     <p:bg>
       <p:bgPr>
         <a:solidFill>
-          <a:srgbClr val="0E1620"/>
+          <a:srgbClr val="16161A"/>
         </a:solidFill>
       </p:bgPr>
     </p:bg>
@@ -2478,7 +2478,7 @@
             <a:r>
               <a:rPr lang="en-US" sz="1000" dirty="0">
                 <a:solidFill>
-                  <a:srgbClr val="94A7B8"/>
+                  <a:srgbClr val="8C887F"/>
                 </a:solidFill>
               </a:rPr>
               <a:t>SmartTraffic · Design of Smart Cities</a:t>
@@ -2517,7 +2517,7 @@
             <a:lvl1pPr>
               <a:defRPr sz="1000">
                 <a:solidFill>
-                  <a:srgbClr val="94A7B8"/>
+                  <a:srgbClr val="8C887F"/>
                 </a:solidFill>
               </a:defRPr>
             </a:lvl1pPr>
@@ -2587,7 +2587,7 @@
             <a:lvl1pPr>
               <a:defRPr sz="1000">
                 <a:solidFill>
-                  <a:srgbClr val="94A7B8"/>
+                  <a:srgbClr val="8C887F"/>
                 </a:solidFill>
               </a:defRPr>
             </a:lvl1pPr>
@@ -2949,7 +2949,7 @@
             <a:r>
               <a:rPr lang="en-US" sz="1800" dirty="0">
                 <a:solidFill>
-                  <a:srgbClr val="94A7B8"/>
+                  <a:srgbClr val="8C887F"/>
                 </a:solidFill>
               </a:rPr>
               <a:t>Adaptive signal control built for lane-less Indian traffic   ·   Design of Smart Cities</a:t>
@@ -2971,15 +2971,15 @@
           </a:xfrm>
           <a:prstGeom prst="roundRect">
             <a:avLst>
-              <a:gd name="adj" fmla="val 5926"/>
+              <a:gd name="adj" fmla="val 1481"/>
             </a:avLst>
           </a:prstGeom>
           <a:solidFill>
-            <a:srgbClr val="1B2A3A"/>
+            <a:srgbClr val="21222A"/>
           </a:solidFill>
           <a:ln w="12700">
             <a:solidFill>
-              <a:srgbClr val="1B2A3A"/>
+              <a:srgbClr val="21222A"/>
             </a:solidFill>
             <a:prstDash val="solid"/>
           </a:ln>
@@ -3023,7 +3023,7 @@
             <a:r>
               <a:rPr lang="en-US" sz="1600" dirty="0">
                 <a:solidFill>
-                  <a:srgbClr val="FFB347"/>
+                  <a:srgbClr val="E8A33D"/>
                 </a:solidFill>
               </a:rPr>
               <a:t>   24BCE5296</a:t>
@@ -3070,7 +3070,7 @@
             <a:r>
               <a:rPr lang="en-US" sz="1600" dirty="0">
                 <a:solidFill>
-                  <a:srgbClr val="FFB347"/>
+                  <a:srgbClr val="E8A33D"/>
                 </a:solidFill>
               </a:rPr>
               <a:t>   24BCE5255</a:t>
@@ -3092,11 +3092,11 @@
           </a:xfrm>
           <a:prstGeom prst="roundRect">
             <a:avLst>
-              <a:gd name="adj" fmla="val 7813"/>
+              <a:gd name="adj" fmla="val 2604"/>
             </a:avLst>
           </a:prstGeom>
           <a:solidFill>
-            <a:srgbClr val="09111A"/>
+            <a:srgbClr val="111115"/>
           </a:solidFill>
           <a:ln w="12700">
             <a:solidFill>
@@ -3121,11 +3121,11 @@
             <a:avLst/>
           </a:prstGeom>
           <a:solidFill>
-            <a:srgbClr val="1B2730"/>
+            <a:srgbClr val="26262C"/>
           </a:solidFill>
           <a:ln w="12700">
             <a:solidFill>
-              <a:srgbClr val="22303C"/>
+              <a:srgbClr val="2E2E34"/>
             </a:solidFill>
             <a:prstDash val="solid"/>
           </a:ln>
@@ -3146,11 +3146,11 @@
             <a:avLst/>
           </a:prstGeom>
           <a:solidFill>
-            <a:srgbClr val="1B2730"/>
+            <a:srgbClr val="26262C"/>
           </a:solidFill>
           <a:ln w="12700">
             <a:solidFill>
-              <a:srgbClr val="22303C"/>
+              <a:srgbClr val="2E2E34"/>
             </a:solidFill>
             <a:prstDash val="solid"/>
           </a:ln>
@@ -3171,11 +3171,11 @@
             <a:avLst/>
           </a:prstGeom>
           <a:solidFill>
-            <a:srgbClr val="3CE87C"/>
+            <a:srgbClr val="6AA84F"/>
           </a:solidFill>
           <a:ln w="12700">
             <a:solidFill>
-              <a:srgbClr val="3CE87C"/>
+              <a:srgbClr val="6AA84F"/>
             </a:solidFill>
             <a:prstDash val="solid"/>
           </a:ln>
@@ -3269,15 +3269,15 @@
           </a:xfrm>
           <a:prstGeom prst="roundRect">
             <a:avLst>
-              <a:gd name="adj" fmla="val 2051"/>
+              <a:gd name="adj" fmla="val 513"/>
             </a:avLst>
           </a:prstGeom>
           <a:solidFill>
-            <a:srgbClr val="1B2A3A"/>
+            <a:srgbClr val="21222A"/>
           </a:solidFill>
           <a:ln w="12700">
             <a:solidFill>
-              <a:srgbClr val="1B2A3A"/>
+              <a:srgbClr val="21222A"/>
             </a:solidFill>
             <a:prstDash val="solid"/>
           </a:ln>
@@ -3310,7 +3310,7 @@
             <a:r>
               <a:rPr lang="en-US" sz="1700" b="1" dirty="0">
                 <a:solidFill>
-                  <a:srgbClr val="94A7B8"/>
+                  <a:srgbClr val="8C887F"/>
                 </a:solidFill>
               </a:rPr>
               <a:t>What the textbooks assume</a:t>
@@ -3368,15 +3368,15 @@
           </a:xfrm>
           <a:prstGeom prst="roundRect">
             <a:avLst>
-              <a:gd name="adj" fmla="val 2051"/>
+              <a:gd name="adj" fmla="val 513"/>
             </a:avLst>
           </a:prstGeom>
           <a:solidFill>
-            <a:srgbClr val="2A2015"/>
+            <a:srgbClr val="2A2114"/>
           </a:solidFill>
           <a:ln w="12700">
             <a:solidFill>
-              <a:srgbClr val="2A2015"/>
+              <a:srgbClr val="2A2114"/>
             </a:solidFill>
             <a:prstDash val="solid"/>
           </a:ln>
@@ -3409,7 +3409,7 @@
             <a:r>
               <a:rPr lang="en-US" sz="1700" b="1" dirty="0">
                 <a:solidFill>
-                  <a:srgbClr val="FFB347"/>
+                  <a:srgbClr val="E8A33D"/>
                 </a:solidFill>
               </a:rPr>
               <a:t>What an Indian junction does</a:t>
@@ -3481,7 +3481,7 @@
             <a:r>
               <a:rPr lang="en-US" sz="1300" i="1" dirty="0">
                 <a:solidFill>
-                  <a:srgbClr val="94A7B8"/>
+                  <a:srgbClr val="8C887F"/>
                 </a:solidFill>
               </a:rPr>
               <a:t>Chennai: 132 hours lost per driver per year, 16 km/h at peak  ·  TomTom 2025</a:t>
@@ -3520,7 +3520,7 @@
             <a:lvl1pPr>
               <a:defRPr sz="1000">
                 <a:solidFill>
-                  <a:srgbClr val="94A7B8"/>
+                  <a:srgbClr val="8C887F"/>
                 </a:solidFill>
               </a:defRPr>
             </a:lvl1pPr>
@@ -3639,15 +3639,15 @@
           </a:xfrm>
           <a:prstGeom prst="roundRect">
             <a:avLst>
-              <a:gd name="adj" fmla="val 1860"/>
+              <a:gd name="adj" fmla="val 465"/>
             </a:avLst>
           </a:prstGeom>
           <a:solidFill>
-            <a:srgbClr val="EEF3F7"/>
+            <a:srgbClr val="E4E0D8"/>
           </a:solidFill>
           <a:ln w="12700">
             <a:solidFill>
-              <a:srgbClr val="EEF3F7"/>
+              <a:srgbClr val="E4E0D8"/>
             </a:solidFill>
             <a:prstDash val="solid"/>
           </a:ln>
@@ -3680,7 +3680,7 @@
             <a:r>
               <a:rPr lang="en-US" sz="5000" b="1" dirty="0">
                 <a:solidFill>
-                  <a:srgbClr val="FF5A5A"/>
+                  <a:srgbClr val="C8503F"/>
                 </a:solidFill>
               </a:rPr>
               <a:t>21.5%</a:t>
@@ -3811,7 +3811,7 @@
             <a:lvl1pPr>
               <a:defRPr sz="1000">
                 <a:solidFill>
-                  <a:srgbClr val="94A7B8"/>
+                  <a:srgbClr val="8C887F"/>
                 </a:solidFill>
               </a:defRPr>
             </a:lvl1pPr>
@@ -3914,15 +3914,15 @@
           </a:xfrm>
           <a:prstGeom prst="roundRect">
             <a:avLst>
-              <a:gd name="adj" fmla="val 1860"/>
+              <a:gd name="adj" fmla="val 465"/>
             </a:avLst>
           </a:prstGeom>
           <a:solidFill>
-            <a:srgbClr val="2A1518"/>
+            <a:srgbClr val="2B1A17"/>
           </a:solidFill>
           <a:ln w="12700">
             <a:solidFill>
-              <a:srgbClr val="2A1518"/>
+              <a:srgbClr val="2B1A17"/>
             </a:solidFill>
             <a:prstDash val="solid"/>
           </a:ln>
@@ -3955,7 +3955,7 @@
             <a:r>
               <a:rPr lang="en-US" sz="1700" b="1" dirty="0">
                 <a:solidFill>
-                  <a:srgbClr val="FF5A5A"/>
+                  <a:srgbClr val="C8503F"/>
                 </a:solidFill>
               </a:rPr>
               <a:t>Correcting the measure was not enough</a:t>
@@ -4033,15 +4033,15 @@
           </a:xfrm>
           <a:prstGeom prst="roundRect">
             <a:avLst>
-              <a:gd name="adj" fmla="val 1860"/>
+              <a:gd name="adj" fmla="val 465"/>
             </a:avLst>
           </a:prstGeom>
           <a:solidFill>
-            <a:srgbClr val="13301F"/>
+            <a:srgbClr val="1C2418"/>
           </a:solidFill>
           <a:ln w="12700">
             <a:solidFill>
-              <a:srgbClr val="13301F"/>
+              <a:srgbClr val="1C2418"/>
             </a:solidFill>
             <a:prstDash val="solid"/>
           </a:ln>
@@ -4074,7 +4074,7 @@
             <a:r>
               <a:rPr lang="en-US" sz="1700" b="1" dirty="0">
                 <a:solidFill>
-                  <a:srgbClr val="3CE87C"/>
+                  <a:srgbClr val="6AA84F"/>
                 </a:solidFill>
               </a:rPr>
               <a:t>So we changed what we optimise</a:t>
@@ -4169,7 +4169,7 @@
             <a:lvl1pPr>
               <a:defRPr sz="1000">
                 <a:solidFill>
-                  <a:srgbClr val="94A7B8"/>
+                  <a:srgbClr val="8C887F"/>
                 </a:solidFill>
               </a:defRPr>
             </a:lvl1pPr>
@@ -4357,7 +4357,7 @@
             <a:lvl1pPr>
               <a:defRPr sz="1000">
                 <a:solidFill>
-                  <a:srgbClr val="94A7B8"/>
+                  <a:srgbClr val="8C887F"/>
                 </a:solidFill>
               </a:defRPr>
             </a:lvl1pPr>
@@ -4460,15 +4460,15 @@
           </a:xfrm>
           <a:prstGeom prst="roundRect">
             <a:avLst>
-              <a:gd name="adj" fmla="val 5926"/>
+              <a:gd name="adj" fmla="val 1481"/>
             </a:avLst>
           </a:prstGeom>
           <a:solidFill>
-            <a:srgbClr val="0E1620"/>
+            <a:srgbClr val="16161A"/>
           </a:solidFill>
           <a:ln w="12700">
             <a:solidFill>
-              <a:srgbClr val="0E1620"/>
+              <a:srgbClr val="16161A"/>
             </a:solidFill>
             <a:prstDash val="solid"/>
           </a:ln>
@@ -4501,11 +4501,11 @@
             <a:r>
               <a:rPr lang="en-US" sz="2000" b="1" dirty="0">
                 <a:solidFill>
-                  <a:srgbClr val="3CE87C"/>
-                </a:solidFill>
-                <a:latin typeface="Courier New" pitchFamily="34" charset="0"/>
-                <a:ea typeface="Courier New" pitchFamily="34" charset="-122"/>
-                <a:cs typeface="Courier New" pitchFamily="34" charset="-120"/>
+                  <a:srgbClr val="6AA84F"/>
+                </a:solidFill>
+                <a:latin typeface="Consolas" pitchFamily="34" charset="0"/>
+                <a:ea typeface="Consolas" pitchFamily="34" charset="-122"/>
+                <a:cs typeface="Consolas" pitchFamily="34" charset="-120"/>
               </a:rPr>
               <a:t>python scripts/reproduce_results.py</a:t>
             </a:r>
@@ -4540,7 +4540,7 @@
             <a:r>
               <a:rPr lang="en-US" sz="1400" dirty="0">
                 <a:solidFill>
-                  <a:srgbClr val="94A7B8"/>
+                  <a:srgbClr val="8C887F"/>
                 </a:solidFill>
               </a:rPr>
               <a:t>Re-measures every documented claim and exits non-zero if one has stopped being true.</a:t>
@@ -4576,7 +4576,7 @@
             <a:r>
               <a:rPr lang="en-US" sz="4400" b="1" dirty="0">
                 <a:solidFill>
-                  <a:srgbClr val="3CE87C"/>
+                  <a:srgbClr val="6AA84F"/>
                 </a:solidFill>
               </a:rPr>
               <a:t>10/10</a:t>
@@ -4778,15 +4778,15 @@
           </a:xfrm>
           <a:prstGeom prst="roundRect">
             <a:avLst>
-              <a:gd name="adj" fmla="val 5333"/>
+              <a:gd name="adj" fmla="val 1333"/>
             </a:avLst>
           </a:prstGeom>
           <a:solidFill>
-            <a:srgbClr val="EEF3F7"/>
+            <a:srgbClr val="E4E0D8"/>
           </a:solidFill>
           <a:ln w="12700">
             <a:solidFill>
-              <a:srgbClr val="EEF3F7"/>
+              <a:srgbClr val="E4E0D8"/>
             </a:solidFill>
             <a:prstDash val="solid"/>
           </a:ln>
@@ -4894,7 +4894,7 @@
             <a:lvl1pPr>
               <a:defRPr sz="1000">
                 <a:solidFill>
-                  <a:srgbClr val="94A7B8"/>
+                  <a:srgbClr val="8C887F"/>
                 </a:solidFill>
               </a:defRPr>
             </a:lvl1pPr>
@@ -5013,7 +5013,7 @@
             <a:r>
               <a:rPr lang="en-US" sz="1800" dirty="0">
                 <a:solidFill>
-                  <a:srgbClr val="94A7B8"/>
+                  <a:srgbClr val="8C887F"/>
                 </a:solidFill>
               </a:rPr>
               <a:t>Control theory imported from the West assumes lane discipline. We modelled lane-less traffic from physics, showed the standard method mis-allocates green by 21%, and fixed the equity problem that correction created.</a:t>
@@ -5035,15 +5035,15 @@
           </a:xfrm>
           <a:prstGeom prst="roundRect">
             <a:avLst>
-              <a:gd name="adj" fmla="val 7273"/>
+              <a:gd name="adj" fmla="val 1818"/>
             </a:avLst>
           </a:prstGeom>
           <a:solidFill>
-            <a:srgbClr val="1B2A3A"/>
+            <a:srgbClr val="21222A"/>
           </a:solidFill>
           <a:ln w="12700">
             <a:solidFill>
-              <a:srgbClr val="1B2A3A"/>
+              <a:srgbClr val="21222A"/>
             </a:solidFill>
             <a:prstDash val="solid"/>
           </a:ln>
@@ -5076,7 +5076,7 @@
             <a:r>
               <a:rPr lang="en-US" sz="1400" dirty="0">
                 <a:solidFill>
-                  <a:srgbClr val="FFB347"/>
+                  <a:srgbClr val="E8A33D"/>
                 </a:solidFill>
               </a:rPr>
               <a:t>Rishab CV · 24BCE5296       Martin Wills · 24BCE5255</a:t>
@@ -5098,11 +5098,11 @@
           </a:xfrm>
           <a:prstGeom prst="roundRect">
             <a:avLst>
-              <a:gd name="adj" fmla="val 7813"/>
+              <a:gd name="adj" fmla="val 2604"/>
             </a:avLst>
           </a:prstGeom>
           <a:solidFill>
-            <a:srgbClr val="09111A"/>
+            <a:srgbClr val="111115"/>
           </a:solidFill>
           <a:ln w="12700">
             <a:solidFill>
@@ -5127,11 +5127,11 @@
             <a:avLst/>
           </a:prstGeom>
           <a:solidFill>
-            <a:srgbClr val="1B2730"/>
+            <a:srgbClr val="26262C"/>
           </a:solidFill>
           <a:ln w="12700">
             <a:solidFill>
-              <a:srgbClr val="22303C"/>
+              <a:srgbClr val="2E2E34"/>
             </a:solidFill>
             <a:prstDash val="solid"/>
           </a:ln>
@@ -5152,11 +5152,11 @@
             <a:avLst/>
           </a:prstGeom>
           <a:solidFill>
-            <a:srgbClr val="1B2730"/>
+            <a:srgbClr val="26262C"/>
           </a:solidFill>
           <a:ln w="12700">
             <a:solidFill>
-              <a:srgbClr val="22303C"/>
+              <a:srgbClr val="2E2E34"/>
             </a:solidFill>
             <a:prstDash val="solid"/>
           </a:ln>
@@ -5177,11 +5177,11 @@
             <a:avLst/>
           </a:prstGeom>
           <a:solidFill>
-            <a:srgbClr val="3CE87C"/>
+            <a:srgbClr val="6AA84F"/>
           </a:solidFill>
           <a:ln w="12700">
             <a:solidFill>
-              <a:srgbClr val="3CE87C"/>
+              <a:srgbClr val="6AA84F"/>
             </a:solidFill>
             <a:prstDash val="solid"/>
           </a:ln>
@@ -5212,40 +5212,40 @@
   <a:themeElements>
     <a:clrScheme name="SmartTraffic Signal">
       <a:dk1>
-        <a:srgbClr val="0E1620"/>
+        <a:srgbClr val="16161A"/>
       </a:dk1>
       <a:lt1>
-        <a:srgbClr val="FFFFFF"/>
+        <a:srgbClr val="F2EFE9"/>
       </a:lt1>
       <a:dk2>
-        <a:srgbClr val="1B2A3A"/>
+        <a:srgbClr val="21222A"/>
       </a:dk2>
       <a:lt2>
-        <a:srgbClr val="EEF3F7"/>
+        <a:srgbClr val="E4E0D8"/>
       </a:lt2>
       <a:accent1>
-        <a:srgbClr val="FFB347"/>
+        <a:srgbClr val="E8A33D"/>
       </a:accent1>
       <a:accent2>
-        <a:srgbClr val="3CE87C"/>
+        <a:srgbClr val="6AA84F"/>
       </a:accent2>
       <a:accent3>
-        <a:srgbClr val="FF5A5A"/>
+        <a:srgbClr val="C8503F"/>
       </a:accent3>
       <a:accent4>
-        <a:srgbClr val="8FD8FF"/>
+        <a:srgbClr val="A8A398"/>
       </a:accent4>
       <a:accent5>
-        <a:srgbClr val="94A7B8"/>
+        <a:srgbClr val="8C887F"/>
       </a:accent5>
       <a:accent6>
-        <a:srgbClr val="C9A227"/>
+        <a:srgbClr val="B0883C"/>
       </a:accent6>
       <a:hlink>
-        <a:srgbClr val="8FD8FF"/>
+        <a:srgbClr val="E8A33D"/>
       </a:hlink>
       <a:folHlink>
-        <a:srgbClr val="94A7B8"/>
+        <a:srgbClr val="8C887F"/>
       </a:folHlink>
     </a:clrScheme>
     <a:fontScheme name="SmartTraffic Signal">

</xml_diff>

<commit_message>
Size the card headings to the text they actually hold
The restyle surfaced overlaps the earlier gap-tightening had introduced:
single-line headings sitting in boxes sized for two lines, running into the
body text beneath them on slides three and four. Sized to fit, then checked
again -- the first attempt went too far the other way and clipped a 39-character
heading, which is exactly why the geometry check exists.
</commit_message>
<xml_diff>
--- a/docs/deck/SmartTraffic-5min.pptx
+++ b/docs/deck/SmartTraffic-5min.pptx
@@ -113,7 +113,7 @@
   <p:extLst>
     <p:ext uri="{521415D9-36F7-43E2-AB2F-B90AF26B5E84}">
       <p14:sectionLst xmlns:p14="http://schemas.microsoft.com/office/powerpoint/2010/main">
-        <p14:section name="Deck" id="{790e9daf-7150-ad02-ac18-6fd701d0d273}">
+        <p14:section name="Deck" id="{c590a7aa-ec02-47ac-2d95-b4a93bf40935}">
           <p14:sldIdLst>
             <p14:sldId id="256"/>
             <p14:sldId id="257"/>
@@ -3698,7 +3698,7 @@
         <p:spPr>
           <a:xfrm>
             <a:off x="7863840" y="2560320"/>
-            <a:ext cx="3383280" cy="548640"/>
+            <a:ext cx="3383280" cy="502920"/>
           </a:xfrm>
           <a:prstGeom prst="rect">
             <a:avLst/>
@@ -3733,8 +3733,8 @@
         </p:nvSpPr>
         <p:spPr>
           <a:xfrm>
-            <a:off x="7863840" y="2971800"/>
-            <a:ext cx="3383280" cy="2194560"/>
+            <a:off x="7863840" y="3154680"/>
+            <a:ext cx="3383280" cy="2011680"/>
           </a:xfrm>
           <a:prstGeom prst="rect">
             <a:avLst/>
@@ -3937,7 +3937,7 @@
         <p:spPr>
           <a:xfrm>
             <a:off x="960120" y="1737360"/>
-            <a:ext cx="4572000" cy="685800"/>
+            <a:ext cx="4572000" cy="457200"/>
           </a:xfrm>
           <a:prstGeom prst="rect">
             <a:avLst/>
@@ -4056,7 +4056,7 @@
         <p:spPr>
           <a:xfrm>
             <a:off x="6629400" y="1737360"/>
-            <a:ext cx="4572000" cy="685800"/>
+            <a:ext cx="4572000" cy="457200"/>
           </a:xfrm>
           <a:prstGeom prst="rect">
             <a:avLst/>

</xml_diff>

<commit_message>
Rewrite the slide copy in a human voice, and fix two stale counts
The prose read like it was generated: no contractions anywhere, every sentence
balanced against its neighbour, em-dashes throughout, and abstract subjects
doing the work -- 'what limits the stop line is lateral space' rather than
saying a scooter takes up less road than a car. Rewritten in plainer, shorter
sentences with concrete subjects. Every em-dash is gone.

Two numbers on the verification slide had gone stale as the project grew: it
still claimed 122 tests and 15 controllers against the current 130 and 16. A
reviewer who ran the suite would have found the deck under-selling itself,
which is a small thing that costs trust out of proportion to its size.

Shortened the slide-two title after the rewrite pushed it onto a second line
and out of its box.
</commit_message>
<xml_diff>
--- a/docs/deck/SmartTraffic-5min.pptx
+++ b/docs/deck/SmartTraffic-5min.pptx
@@ -113,7 +113,7 @@
   <p:extLst>
     <p:ext uri="{521415D9-36F7-43E2-AB2F-B90AF26B5E84}">
       <p14:sectionLst xmlns:p14="http://schemas.microsoft.com/office/powerpoint/2010/main">
-        <p14:section name="Deck" id="{c590a7aa-ec02-47ac-2d95-b4a93bf40935}">
+        <p14:section name="Deck" id="{49513ad4-6ade-7156-f77a-07a5c30a721e}">
           <p14:sldIdLst>
             <p14:sldId id="256"/>
             <p14:sldId id="257"/>
@@ -3250,7 +3250,7 @@
                   <a:schemeClr val="bg1"/>
                 </a:solidFill>
               </a:rPr>
-              <a:t>Signal theory assumes lane discipline</a:t>
+              <a:t>Textbooks assume lanes. We have none.</a:t>
             </a:r>
             <a:endParaRPr lang="en-US" sz="3600" dirty="0"/>
           </a:p>
@@ -3313,7 +3313,7 @@
                   <a:srgbClr val="8C887F"/>
                 </a:solidFill>
               </a:rPr>
-              <a:t>What the textbooks assume</a:t>
+              <a:t>What the textbooks say</a:t>
             </a:r>
             <a:endParaRPr lang="en-US" sz="1700" dirty="0"/>
           </a:p>
@@ -3349,7 +3349,7 @@
                   <a:schemeClr val="bg1"/>
                 </a:solidFill>
               </a:rPr>
-              <a:t>Vehicles queue single file. One crosses per lane per headway. A fixed factor converts a bus or a scooter into "car equivalents".</a:t>
+              <a:t>Traffic queues in neat lanes. One vehicle crosses per lane, per gap. A bus and a scooter both get turned into "car equivalents" using a fixed number.</a:t>
             </a:r>
             <a:endParaRPr lang="en-US" sz="1500" dirty="0"/>
           </a:p>
@@ -3412,7 +3412,7 @@
                   <a:srgbClr val="E8A33D"/>
                 </a:solidFill>
               </a:rPr>
-              <a:t>What an Indian junction does</a:t>
+              <a:t>What actually happens here</a:t>
             </a:r>
             <a:endParaRPr lang="en-US" sz="1700" dirty="0"/>
           </a:p>
@@ -3448,7 +3448,7 @@
                   <a:schemeClr val="bg1"/>
                 </a:solidFill>
               </a:rPr>
-              <a:t>Two-wheelers filter into lateral gaps and cross two or three abreast where one car fits. What limits the stop line is lateral space — not a factor calibrated for moving traffic.</a:t>
+              <a:t>Scooters do not wait their turn in a lane. They filter into gaps and cross three abreast where one car fits. So what really limits a junction is how much width a vehicle takes, not a number borrowed from moving traffic.</a:t>
             </a:r>
             <a:endParaRPr lang="en-US" sz="1500" dirty="0"/>
           </a:p>
@@ -3719,7 +3719,7 @@
                   <a:schemeClr val="tx2"/>
                 </a:solidFill>
               </a:rPr>
-              <a:t>of green wasted at Indian traffic mixes</a:t>
+              <a:t>of the green light is wasted</a:t>
             </a:r>
             <a:endParaRPr lang="en-US" sz="1400" dirty="0"/>
           </a:p>
@@ -3755,7 +3755,7 @@
                   <a:schemeClr val="tx2"/>
                 </a:solidFill>
               </a:rPr>
-              <a:t>Held green after the queue has already cleared. Those seconds are taken from the cross street.</a:t>
+              <a:t>The road stays green after its queue has gone. Those seconds come straight out of the cross street.</a:t>
             </a:r>
             <a:endParaRPr lang="en-US" sz="1300" dirty="0"/>
           </a:p>
@@ -3775,7 +3775,7 @@
                   <a:schemeClr val="tx2"/>
                 </a:solidFill>
               </a:rPr>
-              <a:t>Our model reproduces the textbook figure for cars exactly, so it departs from convention only where lane discipline does.</a:t>
+              <a:t>For cars, our model gives exactly the textbook answer. It only disagrees where lane discipline breaks down.</a:t>
             </a:r>
             <a:endParaRPr lang="en-US" sz="1300" dirty="0"/>
           </a:p>
@@ -3958,7 +3958,7 @@
                   <a:srgbClr val="C8503F"/>
                 </a:solidFill>
               </a:rPr>
-              <a:t>Correcting the measure was not enough</a:t>
+              <a:t>Fixing the measurement was not enough</a:t>
             </a:r>
             <a:endParaRPr lang="en-US" sz="1700" dirty="0"/>
           </a:p>
@@ -3994,7 +3994,7 @@
                   <a:schemeClr val="bg1"/>
                 </a:solidFill>
               </a:rPr>
-              <a:t>Optimising green-seconds-per-vehicle treats a scooter road as cheap, so it scored badly on the very thing being maximised.</a:t>
+              <a:t>Measuring green-seconds per vehicle makes a scooter road look cheap, so it scored badly on the very thing we were maximising.</a:t>
             </a:r>
             <a:endParaRPr lang="en-US" sz="1400" dirty="0"/>
           </a:p>
@@ -4014,7 +4014,7 @@
                   <a:schemeClr val="bg1"/>
                 </a:solidFill>
               </a:rPr>
-              <a:t>It starved that road: 184 ticks of waiting — minutes — falling on the riders least able to absorb it.</a:t>
+              <a:t>It left that road red for 184 ticks. Minutes. And the people waiting were the ones who could least afford to.</a:t>
             </a:r>
             <a:endParaRPr lang="en-US" sz="1400" dirty="0"/>
           </a:p>
@@ -4077,7 +4077,7 @@
                   <a:srgbClr val="6AA84F"/>
                 </a:solidFill>
               </a:rPr>
-              <a:t>So we changed what we optimise</a:t>
+              <a:t>So we changed what we aimed at</a:t>
             </a:r>
             <a:endParaRPr lang="en-US" sz="1700" dirty="0"/>
           </a:p>
@@ -4113,7 +4113,7 @@
                   <a:schemeClr val="bg1"/>
                 </a:solidFill>
               </a:rPr>
-              <a:t>Road efficiency is a constraint, not the goal. The controller now scores each road by people moved per second of green, with a fairness term on accumulated red time.</a:t>
+              <a:t>Efficiency is not the goal, it is a limit. We now score each road by how many people it moves per second of green, plus a fairness term for how long it has been kept waiting.</a:t>
             </a:r>
             <a:endParaRPr lang="en-US" sz="1400" dirty="0"/>
           </a:p>
@@ -4133,7 +4133,7 @@
                   <a:schemeClr val="bg1"/>
                 </a:solidFill>
               </a:rPr>
-              <a:t>Worst-case waiting fell from 184 ticks to 37 — a five-fold cut.</a:t>
+              <a:t>The worst wait dropped from 184 ticks to 37.</a:t>
             </a:r>
             <a:endParaRPr lang="en-US" sz="1400" dirty="0"/>
           </a:p>
@@ -4321,7 +4321,7 @@
                   <a:schemeClr val="tx1"/>
                 </a:solidFill>
               </a:rPr>
-              <a:t>+1,911 ± 848 more people moved than what is deployed today — and no road left starving</a:t>
+              <a:t>1,911 more people moved than today’s method (±848), and no road left starving</a:t>
             </a:r>
             <a:endParaRPr lang="en-US" sz="1500" dirty="0"/>
           </a:p>
@@ -4543,7 +4543,7 @@
                   <a:srgbClr val="8C887F"/>
                 </a:solidFill>
               </a:rPr>
-              <a:t>Re-measures every documented claim and exits non-zero if one has stopped being true.</a:t>
+              <a:t>Re-runs every number in our docs. If one stops being true, the build fails.</a:t>
             </a:r>
             <a:endParaRPr lang="en-US" sz="1400" dirty="0"/>
           </a:p>
@@ -4651,7 +4651,7 @@
                   <a:schemeClr val="tx1"/>
                 </a:solidFill>
               </a:rPr>
-              <a:t>122</a:t>
+              <a:t>130</a:t>
             </a:r>
             <a:endParaRPr lang="en-US" sz="4400" dirty="0"/>
           </a:p>
@@ -4723,7 +4723,7 @@
                   <a:schemeClr val="tx1"/>
                 </a:solidFill>
               </a:rPr>
-              <a:t>15</a:t>
+              <a:t>16</a:t>
             </a:r>
             <a:endParaRPr lang="en-US" sz="4400" dirty="0"/>
           </a:p>
@@ -4858,7 +4858,7 @@
                   <a:schemeClr val="tx2"/>
                 </a:solidFill>
               </a:rPr>
-              <a:t>Discharge parameters are estimates, not measurements from a real junction. It moves more people but fewer vehicles, which is a policy choice. And where every road carries the same traffic it is measurably behind the conventional controller.</a:t>
+              <a:t>Our discharge numbers are estimates, not measurements from a real junction. We move more people but fewer vehicles, and which of those a city wants is their call. And when every road carries the same mix, we are actually behind the conventional one.</a:t>
             </a:r>
             <a:endParaRPr lang="en-US" sz="1300" dirty="0"/>
           </a:p>
@@ -5016,7 +5016,7 @@
                   <a:srgbClr val="8C887F"/>
                 </a:solidFill>
               </a:rPr>
-              <a:t>Control theory imported from the West assumes lane discipline. We modelled lane-less traffic from physics, showed the standard method mis-allocates green by 21%, and fixed the equity problem that correction created.</a:t>
+              <a:t>Signal control was designed for traffic that queues in lanes. Ours is not like that. We worked out how Indian traffic really clears a junction, found the standard method wastes a fifth of the green, then fixed the unfairness our own fix introduced.</a:t>
             </a:r>
             <a:endParaRPr lang="en-US" sz="1800" dirty="0"/>
           </a:p>

</xml_diff>